<commit_message>
Add AI disclosure to source files and deck
</commit_message>
<xml_diff>
--- a/report/evesense_deck.pptx
+++ b/report/evesense_deck.pptx
@@ -14,6 +14,7 @@
     <p:sldId id="262" r:id="rId13"/>
     <p:sldId id="263" r:id="rId14"/>
     <p:sldId id="264" r:id="rId15"/>
+    <p:sldId id="265" r:id="rId16"/>
   </p:sldIdLst>
   <p:sldSz cx="9144000" cy="6858000" type="screen4x3"/>
   <p:notesSz cx="6858000" cy="9144000"/>
@@ -3236,6 +3237,250 @@
                 </a:solidFill>
               </a:rPr>
               <a:t>Quantum Secure Communication track</a:t>
+            </a:r>
+          </a:p>
+        </p:txBody>
+      </p:sp>
+    </p:spTree>
+  </p:cSld>
+  <p:clrMapOvr>
+    <a:masterClrMapping/>
+  </p:clrMapOvr>
+</p:sld>
+</file>
+
+<file path=ppt/slides/slide10.xml><?xml version="1.0" encoding="utf-8"?>
+<p:sld xmlns:a="http://schemas.openxmlformats.org/drawingml/2006/main" xmlns:p="http://schemas.openxmlformats.org/presentationml/2006/main" xmlns:r="http://schemas.openxmlformats.org/officeDocument/2006/relationships">
+  <p:cSld>
+    <p:spTree>
+      <p:nvGrpSpPr>
+        <p:cNvPr id="1" name=""/>
+        <p:cNvGrpSpPr/>
+        <p:nvPr/>
+      </p:nvGrpSpPr>
+      <p:grpSpPr/>
+      <p:sp>
+        <p:nvSpPr>
+          <p:cNvPr id="2" name="TextBox 1"/>
+          <p:cNvSpPr txBox="1"/>
+          <p:nvPr/>
+        </p:nvSpPr>
+        <p:spPr>
+          <a:xfrm>
+            <a:off x="640080" y="457200"/>
+            <a:ext cx="7863840" cy="731520"/>
+          </a:xfrm>
+          <a:prstGeom prst="rect">
+            <a:avLst/>
+          </a:prstGeom>
+          <a:noFill/>
+        </p:spPr>
+        <p:txBody>
+          <a:bodyPr wrap="square">
+            <a:spAutoFit/>
+          </a:bodyPr>
+          <a:lstStyle/>
+          <a:p>
+            <a:pPr>
+              <a:spcAft>
+                <a:spcPts val="800"/>
+              </a:spcAft>
+            </a:pPr>
+            <a:r>
+              <a:rPr sz="3000" b="1">
+                <a:solidFill>
+                  <a:srgbClr val="1F4E79"/>
+                </a:solidFill>
+              </a:rPr>
+              <a:t>Disclosure</a:t>
+            </a:r>
+          </a:p>
+        </p:txBody>
+      </p:sp>
+      <p:sp>
+        <p:nvSpPr>
+          <p:cNvPr id="3" name="TextBox 2"/>
+          <p:cNvSpPr txBox="1"/>
+          <p:nvPr/>
+        </p:nvSpPr>
+        <p:spPr>
+          <a:xfrm>
+            <a:off x="640080" y="1645920"/>
+            <a:ext cx="7863840" cy="3657600"/>
+          </a:xfrm>
+          <a:prstGeom prst="rect">
+            <a:avLst/>
+          </a:prstGeom>
+          <a:noFill/>
+        </p:spPr>
+        <p:txBody>
+          <a:bodyPr wrap="square">
+            <a:spAutoFit/>
+          </a:bodyPr>
+          <a:lstStyle/>
+          <a:p>
+            <a:pPr>
+              <a:spcAft>
+                <a:spcPts val="800"/>
+              </a:spcAft>
+            </a:pPr>
+            <a:r>
+              <a:rPr sz="1500" b="0">
+                <a:solidFill>
+                  <a:srgbClr val="666666"/>
+                </a:solidFill>
+              </a:rPr>
+              <a:t>This project was developed with the assistance of generative AI tools for research,</a:t>
+            </a:r>
+          </a:p>
+          <a:p>
+            <a:pPr>
+              <a:spcAft>
+                <a:spcPts val="800"/>
+              </a:spcAft>
+            </a:pPr>
+            <a:r>
+              <a:rPr sz="1200" b="0">
+                <a:solidFill>
+                  <a:srgbClr val="666666"/>
+                </a:solidFill>
+              </a:rPr>
+              <a:t>structuring and content generation. The final content has been reviewed and</a:t>
+            </a:r>
+          </a:p>
+          <a:p>
+            <a:pPr>
+              <a:spcAft>
+                <a:spcPts val="800"/>
+              </a:spcAft>
+            </a:pPr>
+            <a:r>
+              <a:rPr sz="1200" b="0">
+                <a:solidFill>
+                  <a:srgbClr val="666666"/>
+                </a:solidFill>
+              </a:rPr>
+              <a:t>validated by the author.</a:t>
+            </a:r>
+          </a:p>
+          <a:p>
+            <a:pPr>
+              <a:spcAft>
+                <a:spcPts val="800"/>
+              </a:spcAft>
+            </a:pPr>
+            <a:r>
+              <a:rPr sz="1200" b="0">
+                <a:solidFill>
+                  <a:srgbClr val="666666"/>
+                </a:solidFill>
+              </a:rPr>
+              <a:t/>
+            </a:r>
+          </a:p>
+          <a:p>
+            <a:pPr>
+              <a:spcAft>
+                <a:spcPts val="800"/>
+              </a:spcAft>
+            </a:pPr>
+            <a:r>
+              <a:rPr sz="1200" b="0">
+                <a:solidFill>
+                  <a:srgbClr val="666666"/>
+                </a:solidFill>
+              </a:rPr>
+              <a:t>Full compliance with:</a:t>
+            </a:r>
+          </a:p>
+          <a:p>
+            <a:pPr>
+              <a:spcAft>
+                <a:spcPts val="800"/>
+              </a:spcAft>
+            </a:pPr>
+            <a:r>
+              <a:rPr sz="1200" b="0">
+                <a:solidFill>
+                  <a:srgbClr val="666666"/>
+                </a:solidFill>
+              </a:rPr>
+              <a:t>Reg. (EU) 2024/1689 (AI Act) Art. 50</a:t>
+            </a:r>
+          </a:p>
+          <a:p>
+            <a:pPr>
+              <a:spcAft>
+                <a:spcPts val="800"/>
+              </a:spcAft>
+            </a:pPr>
+            <a:r>
+              <a:rPr sz="1200" b="0">
+                <a:solidFill>
+                  <a:srgbClr val="666666"/>
+                </a:solidFill>
+              </a:rPr>
+              <a:t>Italian Law 132/2025 Art. 13</a:t>
+            </a:r>
+          </a:p>
+          <a:p>
+            <a:pPr>
+              <a:spcAft>
+                <a:spcPts val="800"/>
+              </a:spcAft>
+            </a:pPr>
+            <a:r>
+              <a:rPr sz="1200" b="0">
+                <a:solidFill>
+                  <a:srgbClr val="666666"/>
+                </a:solidFill>
+              </a:rPr>
+              <a:t>EU Code of Practice on AI Transparency (2026)</a:t>
+            </a:r>
+          </a:p>
+          <a:p>
+            <a:pPr>
+              <a:spcAft>
+                <a:spcPts val="800"/>
+              </a:spcAft>
+            </a:pPr>
+            <a:r>
+              <a:rPr sz="1200" b="0">
+                <a:solidFill>
+                  <a:srgbClr val="666666"/>
+                </a:solidFill>
+              </a:rPr>
+              <a:t>U.S. AI Labeling Act (S. 4915) - U.S. H.R.8479</a:t>
+            </a:r>
+          </a:p>
+          <a:p>
+            <a:pPr>
+              <a:spcAft>
+                <a:spcPts val="800"/>
+              </a:spcAft>
+            </a:pPr>
+            <a:r>
+              <a:rPr sz="1200" b="0">
+                <a:solidFill>
+                  <a:srgbClr val="666666"/>
+                </a:solidFill>
+              </a:rPr>
+              <a:t>U.S. Executive Order on AI (Dec 2025)</a:t>
+            </a:r>
+          </a:p>
+          <a:p>
+            <a:pPr>
+              <a:spcAft>
+                <a:spcPts val="800"/>
+              </a:spcAft>
+            </a:pPr>
+            <a:r>
+              <a:rPr sz="1200" b="0">
+                <a:solidFill>
+                  <a:srgbClr val="666666"/>
+                </a:solidFill>
+              </a:rPr>
+              <a:t>California TFAIA &amp; AB 2013 (eff. Jan 2026)</a:t>
             </a:r>
           </a:p>
         </p:txBody>

</xml_diff>

<commit_message>
Fix deck paragraph formatting, add team name to title slide
</commit_message>
<xml_diff>
--- a/report/evesense_deck.pptx
+++ b/report/evesense_deck.pptx
@@ -3121,7 +3121,7 @@
           <a:p>
             <a:pPr>
               <a:spcAft>
-                <a:spcPts val="800"/>
+                <a:spcPts val="1000"/>
               </a:spcAft>
             </a:pPr>
             <a:r>
@@ -3159,7 +3159,7 @@
           <a:p>
             <a:pPr>
               <a:spcAft>
-                <a:spcPts val="800"/>
+                <a:spcPts val="1000"/>
               </a:spcAft>
             </a:pPr>
             <a:r>
@@ -3197,7 +3197,7 @@
           <a:p>
             <a:pPr>
               <a:spcAft>
-                <a:spcPts val="800"/>
+                <a:spcPts val="1000"/>
               </a:spcAft>
             </a:pPr>
             <a:r>
@@ -3206,37 +3206,7 @@
                   <a:srgbClr val="666666"/>
                 </a:solidFill>
               </a:rPr>
-              <a:t>Chiara De Venuto</a:t>
-            </a:r>
-          </a:p>
-          <a:p>
-            <a:pPr>
-              <a:spcAft>
-                <a:spcPts val="800"/>
-              </a:spcAft>
-            </a:pPr>
-            <a:r>
-              <a:rPr sz="1100" b="0">
-                <a:solidFill>
-                  <a:srgbClr val="666666"/>
-                </a:solidFill>
-              </a:rPr>
-              <a:t>Qiskit Fall Fest 2026 @ MPSTME, IBM Quantum</a:t>
-            </a:r>
-          </a:p>
-          <a:p>
-            <a:pPr>
-              <a:spcAft>
-                <a:spcPts val="800"/>
-              </a:spcAft>
-            </a:pPr>
-            <a:r>
-              <a:rPr sz="1100" b="0">
-                <a:solidFill>
-                  <a:srgbClr val="666666"/>
-                </a:solidFill>
-              </a:rPr>
-              <a:t>Quantum Secure Communication track</a:t>
+              <a:t>Chiara De Venuto - team ChiaraDev Qiskit Fall Fest 2026 @ MPSTME, IBM Quantum Quantum Secure Communication track</a:t>
             </a:r>
           </a:p>
         </p:txBody>
@@ -3283,7 +3253,7 @@
           <a:p>
             <a:pPr>
               <a:spcAft>
-                <a:spcPts val="800"/>
+                <a:spcPts val="1000"/>
               </a:spcAft>
             </a:pPr>
             <a:r>
@@ -3321,7 +3291,7 @@
           <a:p>
             <a:pPr>
               <a:spcAft>
-                <a:spcPts val="800"/>
+                <a:spcPts val="1000"/>
               </a:spcAft>
             </a:pPr>
             <a:r>
@@ -3330,157 +3300,22 @@
                   <a:srgbClr val="666666"/>
                 </a:solidFill>
               </a:rPr>
-              <a:t>This project was developed with the assistance of generative AI tools for research,</a:t>
+              <a:t>This project was developed with the assistance of generative AI tools for research, structuring and content generation. The final content has been reviewed and validated by the author.</a:t>
             </a:r>
           </a:p>
           <a:p>
             <a:pPr>
               <a:spcAft>
-                <a:spcPts val="800"/>
+                <a:spcPts val="1000"/>
               </a:spcAft>
             </a:pPr>
             <a:r>
-              <a:rPr sz="1200" b="0">
+              <a:rPr sz="1500" b="0">
                 <a:solidFill>
                   <a:srgbClr val="666666"/>
                 </a:solidFill>
               </a:rPr>
-              <a:t>structuring and content generation. The final content has been reviewed and</a:t>
-            </a:r>
-          </a:p>
-          <a:p>
-            <a:pPr>
-              <a:spcAft>
-                <a:spcPts val="800"/>
-              </a:spcAft>
-            </a:pPr>
-            <a:r>
-              <a:rPr sz="1200" b="0">
-                <a:solidFill>
-                  <a:srgbClr val="666666"/>
-                </a:solidFill>
-              </a:rPr>
-              <a:t>validated by the author.</a:t>
-            </a:r>
-          </a:p>
-          <a:p>
-            <a:pPr>
-              <a:spcAft>
-                <a:spcPts val="800"/>
-              </a:spcAft>
-            </a:pPr>
-            <a:r>
-              <a:rPr sz="1200" b="0">
-                <a:solidFill>
-                  <a:srgbClr val="666666"/>
-                </a:solidFill>
-              </a:rPr>
-              <a:t/>
-            </a:r>
-          </a:p>
-          <a:p>
-            <a:pPr>
-              <a:spcAft>
-                <a:spcPts val="800"/>
-              </a:spcAft>
-            </a:pPr>
-            <a:r>
-              <a:rPr sz="1200" b="0">
-                <a:solidFill>
-                  <a:srgbClr val="666666"/>
-                </a:solidFill>
-              </a:rPr>
-              <a:t>Full compliance with:</a:t>
-            </a:r>
-          </a:p>
-          <a:p>
-            <a:pPr>
-              <a:spcAft>
-                <a:spcPts val="800"/>
-              </a:spcAft>
-            </a:pPr>
-            <a:r>
-              <a:rPr sz="1200" b="0">
-                <a:solidFill>
-                  <a:srgbClr val="666666"/>
-                </a:solidFill>
-              </a:rPr>
-              <a:t>Reg. (EU) 2024/1689 (AI Act) Art. 50</a:t>
-            </a:r>
-          </a:p>
-          <a:p>
-            <a:pPr>
-              <a:spcAft>
-                <a:spcPts val="800"/>
-              </a:spcAft>
-            </a:pPr>
-            <a:r>
-              <a:rPr sz="1200" b="0">
-                <a:solidFill>
-                  <a:srgbClr val="666666"/>
-                </a:solidFill>
-              </a:rPr>
-              <a:t>Italian Law 132/2025 Art. 13</a:t>
-            </a:r>
-          </a:p>
-          <a:p>
-            <a:pPr>
-              <a:spcAft>
-                <a:spcPts val="800"/>
-              </a:spcAft>
-            </a:pPr>
-            <a:r>
-              <a:rPr sz="1200" b="0">
-                <a:solidFill>
-                  <a:srgbClr val="666666"/>
-                </a:solidFill>
-              </a:rPr>
-              <a:t>EU Code of Practice on AI Transparency (2026)</a:t>
-            </a:r>
-          </a:p>
-          <a:p>
-            <a:pPr>
-              <a:spcAft>
-                <a:spcPts val="800"/>
-              </a:spcAft>
-            </a:pPr>
-            <a:r>
-              <a:rPr sz="1200" b="0">
-                <a:solidFill>
-                  <a:srgbClr val="666666"/>
-                </a:solidFill>
-              </a:rPr>
-              <a:t>U.S. AI Labeling Act (S. 4915) - U.S. H.R.8479</a:t>
-            </a:r>
-          </a:p>
-          <a:p>
-            <a:pPr>
-              <a:spcAft>
-                <a:spcPts val="800"/>
-              </a:spcAft>
-            </a:pPr>
-            <a:r>
-              <a:rPr sz="1200" b="0">
-                <a:solidFill>
-                  <a:srgbClr val="666666"/>
-                </a:solidFill>
-              </a:rPr>
-              <a:t>U.S. Executive Order on AI (Dec 2025)</a:t>
-            </a:r>
-          </a:p>
-          <a:p>
-            <a:pPr>
-              <a:spcAft>
-                <a:spcPts val="800"/>
-              </a:spcAft>
-            </a:pPr>
-            <a:r>
-              <a:rPr sz="1200" b="0">
-                <a:solidFill>
-                  <a:srgbClr val="666666"/>
-                </a:solidFill>
-              </a:rPr>
-              <a:t>California TFAIA &amp; AB 2013 (eff. Jan 2026)</a:t>
+              <a:t>Full compliance with: Reg. (EU) 2024/1689 (AI Act) Art. 50 Italian Law 132/2025 Art. 13 EU Code of Practice on AI Transparency (2026) U.S. AI Labeling Act (S. 4915) - U.S. H.R.8479 U.S. Executive Order on AI (Dec 2025) California TFAIA &amp; AB 2013 (eff. Jan 2026)</a:t>
             </a:r>
           </a:p>
         </p:txBody>
@@ -3527,7 +3362,7 @@
           <a:p>
             <a:pPr>
               <a:spcAft>
-                <a:spcPts val="800"/>
+                <a:spcPts val="1000"/>
               </a:spcAft>
             </a:pPr>
             <a:r>
@@ -3565,7 +3400,7 @@
           <a:p>
             <a:pPr>
               <a:spcAft>
-                <a:spcPts val="800"/>
+                <a:spcPts val="1000"/>
               </a:spcAft>
             </a:pPr>
             <a:r>
@@ -3574,202 +3409,37 @@
                   <a:srgbClr val="1A1A1A"/>
                 </a:solidFill>
               </a:rPr>
-              <a:t>BB84 security rests on one fact: measuring a qubit in the wrong basis</a:t>
+              <a:t>BB84 security rests on one fact: measuring a qubit in the wrong basis disturbs it. An intercept-resend attacker inserts errors, the two ends read those errors as QBER, and above roughly 11% QBER the link stops producing usable key.</a:t>
             </a:r>
           </a:p>
           <a:p>
             <a:pPr>
               <a:spcAft>
-                <a:spcPts val="800"/>
+                <a:spcPts val="1000"/>
               </a:spcAft>
             </a:pPr>
             <a:r>
-              <a:rPr sz="1300" b="0">
+              <a:rPr sz="1600" b="0">
                 <a:solidFill>
                   <a:srgbClr val="1A1A1A"/>
                 </a:solidFill>
               </a:rPr>
-              <a:t>disturbs it. An intercept-resend attacker inserts errors, the two ends</a:t>
+              <a:t>Deployed fiber is never clean. Raman scattering, dark counts and polarization drift put real links at a few percent QBER with nobody listening. So the receiver is not comparing a measurement against zero. It is comparing against a baseline that moves.</a:t>
             </a:r>
           </a:p>
           <a:p>
             <a:pPr>
               <a:spcAft>
-                <a:spcPts val="800"/>
+                <a:spcPts val="1000"/>
               </a:spcAft>
             </a:pPr>
             <a:r>
-              <a:rPr sz="1300" b="0">
+              <a:rPr sz="1600" b="0">
                 <a:solidFill>
                   <a:srgbClr val="1A1A1A"/>
                 </a:solidFill>
               </a:rPr>
-              <a:t>read those errors as QBER, and above roughly 11% QBER the link stops</a:t>
-            </a:r>
-          </a:p>
-          <a:p>
-            <a:pPr>
-              <a:spcAft>
-                <a:spcPts val="800"/>
-              </a:spcAft>
-            </a:pPr>
-            <a:r>
-              <a:rPr sz="1300" b="0">
-                <a:solidFill>
-                  <a:srgbClr val="1A1A1A"/>
-                </a:solidFill>
-              </a:rPr>
-              <a:t>producing usable key.</a:t>
-            </a:r>
-          </a:p>
-          <a:p>
-            <a:pPr>
-              <a:spcAft>
-                <a:spcPts val="800"/>
-              </a:spcAft>
-            </a:pPr>
-            <a:r>
-              <a:rPr sz="1300" b="0">
-                <a:solidFill>
-                  <a:srgbClr val="1A1A1A"/>
-                </a:solidFill>
-              </a:rPr>
-              <a:t/>
-            </a:r>
-          </a:p>
-          <a:p>
-            <a:pPr>
-              <a:spcAft>
-                <a:spcPts val="800"/>
-              </a:spcAft>
-            </a:pPr>
-            <a:r>
-              <a:rPr sz="1300" b="0">
-                <a:solidFill>
-                  <a:srgbClr val="1A1A1A"/>
-                </a:solidFill>
-              </a:rPr>
-              <a:t>Deployed fiber is never clean. Raman scattering, dark counts and</a:t>
-            </a:r>
-          </a:p>
-          <a:p>
-            <a:pPr>
-              <a:spcAft>
-                <a:spcPts val="800"/>
-              </a:spcAft>
-            </a:pPr>
-            <a:r>
-              <a:rPr sz="1300" b="0">
-                <a:solidFill>
-                  <a:srgbClr val="1A1A1A"/>
-                </a:solidFill>
-              </a:rPr>
-              <a:t>polarization drift put real links at a few percent QBER with nobody</a:t>
-            </a:r>
-          </a:p>
-          <a:p>
-            <a:pPr>
-              <a:spcAft>
-                <a:spcPts val="800"/>
-              </a:spcAft>
-            </a:pPr>
-            <a:r>
-              <a:rPr sz="1300" b="0">
-                <a:solidFill>
-                  <a:srgbClr val="1A1A1A"/>
-                </a:solidFill>
-              </a:rPr>
-              <a:t>listening. So the receiver is not comparing a measurement against</a:t>
-            </a:r>
-          </a:p>
-          <a:p>
-            <a:pPr>
-              <a:spcAft>
-                <a:spcPts val="800"/>
-              </a:spcAft>
-            </a:pPr>
-            <a:r>
-              <a:rPr sz="1300" b="0">
-                <a:solidFill>
-                  <a:srgbClr val="1A1A1A"/>
-                </a:solidFill>
-              </a:rPr>
-              <a:t>zero. It is comparing against a baseline that moves.</a:t>
-            </a:r>
-          </a:p>
-          <a:p>
-            <a:pPr>
-              <a:spcAft>
-                <a:spcPts val="800"/>
-              </a:spcAft>
-            </a:pPr>
-            <a:r>
-              <a:rPr sz="1300" b="0">
-                <a:solidFill>
-                  <a:srgbClr val="1A1A1A"/>
-                </a:solidFill>
-              </a:rPr>
-              <a:t/>
-            </a:r>
-          </a:p>
-          <a:p>
-            <a:pPr>
-              <a:spcAft>
-                <a:spcPts val="800"/>
-              </a:spcAft>
-            </a:pPr>
-            <a:r>
-              <a:rPr sz="1300" b="0">
-                <a:solidFill>
-                  <a:srgbClr val="1A1A1A"/>
-                </a:solidFill>
-              </a:rPr>
-              <a:t>Eve knows the baseline. A patient attacker keeps her interception</a:t>
-            </a:r>
-          </a:p>
-          <a:p>
-            <a:pPr>
-              <a:spcAft>
-                <a:spcPts val="800"/>
-              </a:spcAft>
-            </a:pPr>
-            <a:r>
-              <a:rPr sz="1300" b="0">
-                <a:solidFill>
-                  <a:srgbClr val="1A1A1A"/>
-                </a:solidFill>
-              </a:rPr>
-              <a:t>rate under the noise floor. The receiver has one number and one</a:t>
-            </a:r>
-          </a:p>
-          <a:p>
-            <a:pPr>
-              <a:spcAft>
-                <a:spcPts val="800"/>
-              </a:spcAft>
-            </a:pPr>
-            <a:r>
-              <a:rPr sz="1300" b="0">
-                <a:solidFill>
-                  <a:srgbClr val="1A1A1A"/>
-                </a:solidFill>
-              </a:rPr>
-              <a:t>threshold, and has to decide whether a rise in QBER is Eve or the</a:t>
-            </a:r>
-          </a:p>
-          <a:p>
-            <a:pPr>
-              <a:spcAft>
-                <a:spcPts val="800"/>
-              </a:spcAft>
-            </a:pPr>
-            <a:r>
-              <a:rPr sz="1300" b="0">
-                <a:solidFill>
-                  <a:srgbClr val="1A1A1A"/>
-                </a:solidFill>
-              </a:rPr>
-              <a:t>weather.</a:t>
+              <a:t>Eve knows the baseline. A patient attacker keeps her interception rate under the noise floor. The receiver has one number and one threshold, and has to decide whether a rise in QBER is Eve or the weather.</a:t>
             </a:r>
           </a:p>
         </p:txBody>
@@ -3816,7 +3486,7 @@
           <a:p>
             <a:pPr>
               <a:spcAft>
-                <a:spcPts val="800"/>
+                <a:spcPts val="1000"/>
               </a:spcAft>
             </a:pPr>
             <a:r>
@@ -3854,7 +3524,7 @@
           <a:p>
             <a:pPr>
               <a:spcAft>
-                <a:spcPts val="800"/>
+                <a:spcPts val="1000"/>
               </a:spcAft>
             </a:pPr>
             <a:r>
@@ -3863,202 +3533,52 @@
                   <a:srgbClr val="1A1A1A"/>
                 </a:solidFill>
               </a:rPr>
-              <a:t>A BB84 link in Qiskit with a tunable attacker and a tunable channel,</a:t>
+              <a:t>A BB84 link in Qiskit with a tunable attacker and a tunable channel, then a detection study across nine conditions.</a:t>
             </a:r>
           </a:p>
           <a:p>
             <a:pPr>
               <a:spcAft>
-                <a:spcPts val="800"/>
+                <a:spcPts val="1000"/>
               </a:spcAft>
             </a:pPr>
             <a:r>
-              <a:rPr sz="1300" b="0">
+              <a:rPr sz="1600" b="0">
                 <a:solidFill>
                   <a:srgbClr val="1A1A1A"/>
                 </a:solidFill>
               </a:rPr>
-              <a:t>then a detection study across nine conditions.</a:t>
+              <a:t>One round is one qubit: Alice prepares |0&gt;, |1&gt;, |+&gt; or |-&gt;, Eve intercept-measures and resends when she is active, the channel adds depolarizing and readout noise, Bob measures in the basis he picked.</a:t>
             </a:r>
           </a:p>
           <a:p>
             <a:pPr>
               <a:spcAft>
-                <a:spcPts val="800"/>
+                <a:spcPts val="1000"/>
               </a:spcAft>
             </a:pPr>
             <a:r>
-              <a:rPr sz="1300" b="0">
+              <a:rPr sz="1600" b="0">
                 <a:solidFill>
                   <a:srgbClr val="1A1A1A"/>
                 </a:solidFill>
               </a:rPr>
-              <a:t/>
+              <a:t>Rounds are packed into batches of 64 qubits in a single stabilizer circuit, so 30000 rounds cost milliseconds. Eve's outcome is drawn from the Born rule, which is what a mid-circuit measure-and-resend gives.</a:t>
             </a:r>
           </a:p>
           <a:p>
             <a:pPr>
               <a:spcAft>
-                <a:spcPts val="800"/>
+                <a:spcPts val="1000"/>
               </a:spcAft>
             </a:pPr>
             <a:r>
-              <a:rPr sz="1300" b="0">
+              <a:rPr sz="1600" b="0">
                 <a:solidFill>
                   <a:srgbClr val="1A1A1A"/>
                 </a:solidFill>
               </a:rPr>
-              <a:t>One round is one qubit: Alice prepares |0&gt;, |1&gt;, |+&gt; or |-&gt;, Eve</a:t>
-            </a:r>
-          </a:p>
-          <a:p>
-            <a:pPr>
-              <a:spcAft>
-                <a:spcPts val="800"/>
-              </a:spcAft>
-            </a:pPr>
-            <a:r>
-              <a:rPr sz="1300" b="0">
-                <a:solidFill>
-                  <a:srgbClr val="1A1A1A"/>
-                </a:solidFill>
-              </a:rPr>
-              <a:t>intercept-measures and resends when she is active, the channel adds</a:t>
-            </a:r>
-          </a:p>
-          <a:p>
-            <a:pPr>
-              <a:spcAft>
-                <a:spcPts val="800"/>
-              </a:spcAft>
-            </a:pPr>
-            <a:r>
-              <a:rPr sz="1300" b="0">
-                <a:solidFill>
-                  <a:srgbClr val="1A1A1A"/>
-                </a:solidFill>
-              </a:rPr>
-              <a:t>depolarizing and readout noise, Bob measures in the basis he picked.</a:t>
-            </a:r>
-          </a:p>
-          <a:p>
-            <a:pPr>
-              <a:spcAft>
-                <a:spcPts val="800"/>
-              </a:spcAft>
-            </a:pPr>
-            <a:r>
-              <a:rPr sz="1300" b="0">
-                <a:solidFill>
-                  <a:srgbClr val="1A1A1A"/>
-                </a:solidFill>
-              </a:rPr>
-              <a:t/>
-            </a:r>
-          </a:p>
-          <a:p>
-            <a:pPr>
-              <a:spcAft>
-                <a:spcPts val="800"/>
-              </a:spcAft>
-            </a:pPr>
-            <a:r>
-              <a:rPr sz="1300" b="0">
-                <a:solidFill>
-                  <a:srgbClr val="1A1A1A"/>
-                </a:solidFill>
-              </a:rPr>
-              <a:t>Rounds are packed into batches of 64 qubits in a single stabilizer</a:t>
-            </a:r>
-          </a:p>
-          <a:p>
-            <a:pPr>
-              <a:spcAft>
-                <a:spcPts val="800"/>
-              </a:spcAft>
-            </a:pPr>
-            <a:r>
-              <a:rPr sz="1300" b="0">
-                <a:solidFill>
-                  <a:srgbClr val="1A1A1A"/>
-                </a:solidFill>
-              </a:rPr>
-              <a:t>circuit, so 30000 rounds cost milliseconds. Eve's outcome is drawn</a:t>
-            </a:r>
-          </a:p>
-          <a:p>
-            <a:pPr>
-              <a:spcAft>
-                <a:spcPts val="800"/>
-              </a:spcAft>
-            </a:pPr>
-            <a:r>
-              <a:rPr sz="1300" b="0">
-                <a:solidFill>
-                  <a:srgbClr val="1A1A1A"/>
-                </a:solidFill>
-              </a:rPr>
-              <a:t>from the Born rule, which is what a mid-circuit measure-and-resend</a:t>
-            </a:r>
-          </a:p>
-          <a:p>
-            <a:pPr>
-              <a:spcAft>
-                <a:spcPts val="800"/>
-              </a:spcAft>
-            </a:pPr>
-            <a:r>
-              <a:rPr sz="1300" b="0">
-                <a:solidFill>
-                  <a:srgbClr val="1A1A1A"/>
-                </a:solidFill>
-              </a:rPr>
-              <a:t>gives.</a:t>
-            </a:r>
-          </a:p>
-          <a:p>
-            <a:pPr>
-              <a:spcAft>
-                <a:spcPts val="800"/>
-              </a:spcAft>
-            </a:pPr>
-            <a:r>
-              <a:rPr sz="1300" b="0">
-                <a:solidFill>
-                  <a:srgbClr val="1A1A1A"/>
-                </a:solidFill>
-              </a:rPr>
-              <a:t/>
-            </a:r>
-          </a:p>
-          <a:p>
-            <a:pPr>
-              <a:spcAft>
-                <a:spcPts val="800"/>
-              </a:spcAft>
-            </a:pPr>
-            <a:r>
-              <a:rPr sz="1300" b="0">
-                <a:solidFill>
-                  <a:srgbClr val="1A1A1A"/>
-                </a:solidFill>
-              </a:rPr>
-              <a:t>Four experiments: interception sweep, channel noise sweep, detection</a:t>
-            </a:r>
-          </a:p>
-          <a:p>
-            <a:pPr>
-              <a:spcAft>
-                <a:spcPts val="800"/>
-              </a:spcAft>
-            </a:pPr>
-            <a:r>
-              <a:rPr sz="1300" b="0">
-                <a:solidFill>
-                  <a:srgbClr val="1A1A1A"/>
-                </a:solidFill>
-              </a:rPr>
-              <a:t>study with 12 repeats per condition, and the secure key rate curve.</a:t>
+              <a:t>Four experiments: interception sweep, channel noise sweep, detection study with 12 repeats per condition, and the secure key rate curve.</a:t>
             </a:r>
           </a:p>
         </p:txBody>
@@ -4105,7 +3625,7 @@
           <a:p>
             <a:pPr>
               <a:spcAft>
-                <a:spcPts val="800"/>
+                <a:spcPts val="1000"/>
               </a:spcAft>
             </a:pPr>
             <a:r>
@@ -4167,7 +3687,7 @@
           <a:p>
             <a:pPr>
               <a:spcAft>
-                <a:spcPts val="800"/>
+                <a:spcPts val="1000"/>
               </a:spcAft>
             </a:pPr>
             <a:r>
@@ -4223,7 +3743,7 @@
           <a:p>
             <a:pPr>
               <a:spcAft>
-                <a:spcPts val="800"/>
+                <a:spcPts val="1000"/>
               </a:spcAft>
             </a:pPr>
             <a:r>
@@ -4285,7 +3805,7 @@
           <a:p>
             <a:pPr>
               <a:spcAft>
-                <a:spcPts val="800"/>
+                <a:spcPts val="1000"/>
               </a:spcAft>
             </a:pPr>
             <a:r>
@@ -4341,7 +3861,7 @@
           <a:p>
             <a:pPr>
               <a:spcAft>
-                <a:spcPts val="800"/>
+                <a:spcPts val="1000"/>
               </a:spcAft>
             </a:pPr>
             <a:r>
@@ -4403,7 +3923,7 @@
           <a:p>
             <a:pPr>
               <a:spcAft>
-                <a:spcPts val="800"/>
+                <a:spcPts val="1000"/>
               </a:spcAft>
             </a:pPr>
             <a:r>
@@ -4459,7 +3979,7 @@
           <a:p>
             <a:pPr>
               <a:spcAft>
-                <a:spcPts val="800"/>
+                <a:spcPts val="1000"/>
               </a:spcAft>
             </a:pPr>
             <a:r>
@@ -4521,7 +4041,7 @@
           <a:p>
             <a:pPr>
               <a:spcAft>
-                <a:spcPts val="800"/>
+                <a:spcPts val="1000"/>
               </a:spcAft>
             </a:pPr>
             <a:r>
@@ -4577,7 +4097,7 @@
           <a:p>
             <a:pPr>
               <a:spcAft>
-                <a:spcPts val="800"/>
+                <a:spcPts val="1000"/>
               </a:spcAft>
             </a:pPr>
             <a:r>
@@ -4615,7 +4135,7 @@
           <a:p>
             <a:pPr>
               <a:spcAft>
-                <a:spcPts val="800"/>
+                <a:spcPts val="1000"/>
               </a:spcAft>
             </a:pPr>
             <a:r>
@@ -4624,232 +4144,52 @@
                   <a:srgbClr val="1A1A1A"/>
                 </a:solidFill>
               </a:rPr>
-              <a:t>On a clean link the protocol behaves exactly as theory predicts: QBER</a:t>
+              <a:t>On a clean link the protocol behaves exactly as theory predicts: QBER tracks 25% of the interception probability, and the measured curve sits on the analytical one.</a:t>
             </a:r>
           </a:p>
           <a:p>
             <a:pPr>
               <a:spcAft>
-                <a:spcPts val="800"/>
+                <a:spcPts val="1000"/>
               </a:spcAft>
             </a:pPr>
             <a:r>
-              <a:rPr sz="1200" b="0">
+              <a:rPr sz="1500" b="0">
                 <a:solidFill>
                   <a:srgbClr val="1A1A1A"/>
                 </a:solidFill>
               </a:rPr>
-              <a:t>tracks 25% of the interception probability, and the measured curve</a:t>
+              <a:t>A 7% depolarizing channel on its own produces about 7% QBER. That is the same order of magnitude as a 10% interception rate on clean fiber. The receiver cannot tell those two apart from a single measurement.</a:t>
             </a:r>
           </a:p>
           <a:p>
             <a:pPr>
               <a:spcAft>
-                <a:spcPts val="800"/>
+                <a:spcPts val="1000"/>
               </a:spcAft>
             </a:pPr>
             <a:r>
-              <a:rPr sz="1200" b="0">
+              <a:rPr sz="1500" b="0">
                 <a:solidFill>
                   <a:srgbClr val="1A1A1A"/>
                 </a:solidFill>
               </a:rPr>
-              <a:t>sits on the analytical one.</a:t>
+              <a:t>The ROC curves show the tradeoff. On clean fiber almost any threshold separates tapped from untapped. On dirty fiber the curve collapses toward the diagonal at low interception rates, which is where a patient attacker works.</a:t>
             </a:r>
           </a:p>
           <a:p>
             <a:pPr>
               <a:spcAft>
-                <a:spcPts val="800"/>
+                <a:spcPts val="1000"/>
               </a:spcAft>
             </a:pPr>
             <a:r>
-              <a:rPr sz="1200" b="0">
+              <a:rPr sz="1500" b="0">
                 <a:solidFill>
                   <a:srgbClr val="1A1A1A"/>
                 </a:solidFill>
               </a:rPr>
-              <a:t/>
-            </a:r>
-          </a:p>
-          <a:p>
-            <a:pPr>
-              <a:spcAft>
-                <a:spcPts val="800"/>
-              </a:spcAft>
-            </a:pPr>
-            <a:r>
-              <a:rPr sz="1200" b="0">
-                <a:solidFill>
-                  <a:srgbClr val="1A1A1A"/>
-                </a:solidFill>
-              </a:rPr>
-              <a:t>A 7% depolarizing channel on its own produces about 7% QBER. That</a:t>
-            </a:r>
-          </a:p>
-          <a:p>
-            <a:pPr>
-              <a:spcAft>
-                <a:spcPts val="800"/>
-              </a:spcAft>
-            </a:pPr>
-            <a:r>
-              <a:rPr sz="1200" b="0">
-                <a:solidFill>
-                  <a:srgbClr val="1A1A1A"/>
-                </a:solidFill>
-              </a:rPr>
-              <a:t>is the same order of magnitude as a 10% interception rate on clean</a:t>
-            </a:r>
-          </a:p>
-          <a:p>
-            <a:pPr>
-              <a:spcAft>
-                <a:spcPts val="800"/>
-              </a:spcAft>
-            </a:pPr>
-            <a:r>
-              <a:rPr sz="1200" b="0">
-                <a:solidFill>
-                  <a:srgbClr val="1A1A1A"/>
-                </a:solidFill>
-              </a:rPr>
-              <a:t>fiber. The receiver cannot tell those two apart from a single</a:t>
-            </a:r>
-          </a:p>
-          <a:p>
-            <a:pPr>
-              <a:spcAft>
-                <a:spcPts val="800"/>
-              </a:spcAft>
-            </a:pPr>
-            <a:r>
-              <a:rPr sz="1200" b="0">
-                <a:solidFill>
-                  <a:srgbClr val="1A1A1A"/>
-                </a:solidFill>
-              </a:rPr>
-              <a:t>measurement.</a:t>
-            </a:r>
-          </a:p>
-          <a:p>
-            <a:pPr>
-              <a:spcAft>
-                <a:spcPts val="800"/>
-              </a:spcAft>
-            </a:pPr>
-            <a:r>
-              <a:rPr sz="1200" b="0">
-                <a:solidFill>
-                  <a:srgbClr val="1A1A1A"/>
-                </a:solidFill>
-              </a:rPr>
-              <a:t/>
-            </a:r>
-          </a:p>
-          <a:p>
-            <a:pPr>
-              <a:spcAft>
-                <a:spcPts val="800"/>
-              </a:spcAft>
-            </a:pPr>
-            <a:r>
-              <a:rPr sz="1200" b="0">
-                <a:solidFill>
-                  <a:srgbClr val="1A1A1A"/>
-                </a:solidFill>
-              </a:rPr>
-              <a:t>The ROC curves show the tradeoff. On clean fiber almost any</a:t>
-            </a:r>
-          </a:p>
-          <a:p>
-            <a:pPr>
-              <a:spcAft>
-                <a:spcPts val="800"/>
-              </a:spcAft>
-            </a:pPr>
-            <a:r>
-              <a:rPr sz="1200" b="0">
-                <a:solidFill>
-                  <a:srgbClr val="1A1A1A"/>
-                </a:solidFill>
-              </a:rPr>
-              <a:t>threshold separates tapped from untapped. On dirty fiber the curve</a:t>
-            </a:r>
-          </a:p>
-          <a:p>
-            <a:pPr>
-              <a:spcAft>
-                <a:spcPts val="800"/>
-              </a:spcAft>
-            </a:pPr>
-            <a:r>
-              <a:rPr sz="1200" b="0">
-                <a:solidFill>
-                  <a:srgbClr val="1A1A1A"/>
-                </a:solidFill>
-              </a:rPr>
-              <a:t>collapses toward the diagonal at low interception rates, which is</a:t>
-            </a:r>
-          </a:p>
-          <a:p>
-            <a:pPr>
-              <a:spcAft>
-                <a:spcPts val="800"/>
-              </a:spcAft>
-            </a:pPr>
-            <a:r>
-              <a:rPr sz="1200" b="0">
-                <a:solidFill>
-                  <a:srgbClr val="1A1A1A"/>
-                </a:solidFill>
-              </a:rPr>
-              <a:t>where a patient attacker works.</a:t>
-            </a:r>
-          </a:p>
-          <a:p>
-            <a:pPr>
-              <a:spcAft>
-                <a:spcPts val="800"/>
-              </a:spcAft>
-            </a:pPr>
-            <a:r>
-              <a:rPr sz="1200" b="0">
-                <a:solidFill>
-                  <a:srgbClr val="1A1A1A"/>
-                </a:solidFill>
-              </a:rPr>
-              <a:t/>
-            </a:r>
-          </a:p>
-          <a:p>
-            <a:pPr>
-              <a:spcAft>
-                <a:spcPts val="800"/>
-              </a:spcAft>
-            </a:pPr>
-            <a:r>
-              <a:rPr sz="1200" b="0">
-                <a:solidFill>
-                  <a:srgbClr val="1A1A1A"/>
-                </a:solidFill>
-              </a:rPr>
-              <a:t>Past about 11% QBER error correction and privacy amplification take</a:t>
-            </a:r>
-          </a:p>
-          <a:p>
-            <a:pPr>
-              <a:spcAft>
-                <a:spcPts val="800"/>
-              </a:spcAft>
-            </a:pPr>
-            <a:r>
-              <a:rPr sz="1200" b="0">
-                <a:solidFill>
-                  <a:srgbClr val="1A1A1A"/>
-                </a:solidFill>
-              </a:rPr>
-              <a:t>everything. The link stays up and stops being worth anything.</a:t>
+              <a:t>Past about 11% QBER error correction and privacy amplification take everything. The link stays up and stops being worth anything.</a:t>
             </a:r>
           </a:p>
         </p:txBody>
@@ -4896,7 +4236,7 @@
           <a:p>
             <a:pPr>
               <a:spcAft>
-                <a:spcPts val="800"/>
+                <a:spcPts val="1000"/>
               </a:spcAft>
             </a:pPr>
             <a:r>
@@ -4934,7 +4274,7 @@
           <a:p>
             <a:pPr>
               <a:spcAft>
-                <a:spcPts val="800"/>
+                <a:spcPts val="1000"/>
               </a:spcAft>
             </a:pPr>
             <a:r>
@@ -4943,202 +4283,52 @@
                   <a:srgbClr val="1A1A1A"/>
                 </a:solidFill>
               </a:rPr>
-              <a:t>Eve here is a textbook intercept-resend attacker. Photon-number-</a:t>
+              <a:t>Eve here is a textbook intercept-resend attacker. Photon-number- splitting and coherent attacks are not in the model, and nothing in this work is a security proof.</a:t>
             </a:r>
           </a:p>
           <a:p>
             <a:pPr>
               <a:spcAft>
-                <a:spcPts val="800"/>
+                <a:spcPts val="1000"/>
               </a:spcAft>
             </a:pPr>
             <a:r>
-              <a:rPr sz="1200" b="0">
+              <a:rPr sz="1500" b="0">
                 <a:solidFill>
                   <a:srgbClr val="1A1A1A"/>
                 </a:solidFill>
               </a:rPr>
-              <a:t>splitting and coherent attacks are not in the model, and nothing in</a:t>
+              <a:t>The channel is depolarizing plus symmetric readout noise. Real fiber drifts in polarization and loses differently per wavelength.</a:t>
             </a:r>
           </a:p>
           <a:p>
             <a:pPr>
               <a:spcAft>
-                <a:spcPts val="800"/>
+                <a:spcPts val="1000"/>
               </a:spcAft>
             </a:pPr>
             <a:r>
-              <a:rPr sz="1200" b="0">
+              <a:rPr sz="1500" b="0">
                 <a:solidFill>
                   <a:srgbClr val="1A1A1A"/>
                 </a:solidFill>
               </a:rPr>
-              <a:t>this work is a security proof.</a:t>
+              <a:t>The detector is a single threshold. A real receiver discloses part of the key, estimates QBER on that subset and adapts the threshold against a measured baseline instead of a fixed number.</a:t>
             </a:r>
           </a:p>
           <a:p>
             <a:pPr>
               <a:spcAft>
-                <a:spcPts val="800"/>
+                <a:spcPts val="1000"/>
               </a:spcAft>
             </a:pPr>
             <a:r>
-              <a:rPr sz="1200" b="0">
+              <a:rPr sz="1500" b="0">
                 <a:solidFill>
                   <a:srgbClr val="1A1A1A"/>
                 </a:solidFill>
               </a:rPr>
-              <a:t/>
-            </a:r>
-          </a:p>
-          <a:p>
-            <a:pPr>
-              <a:spcAft>
-                <a:spcPts val="800"/>
-              </a:spcAft>
-            </a:pPr>
-            <a:r>
-              <a:rPr sz="1200" b="0">
-                <a:solidFill>
-                  <a:srgbClr val="1A1A1A"/>
-                </a:solidFill>
-              </a:rPr>
-              <a:t>The channel is depolarizing plus symmetric readout noise. Real fiber</a:t>
-            </a:r>
-          </a:p>
-          <a:p>
-            <a:pPr>
-              <a:spcAft>
-                <a:spcPts val="800"/>
-              </a:spcAft>
-            </a:pPr>
-            <a:r>
-              <a:rPr sz="1200" b="0">
-                <a:solidFill>
-                  <a:srgbClr val="1A1A1A"/>
-                </a:solidFill>
-              </a:rPr>
-              <a:t>drifts in polarization and loses differently per wavelength.</a:t>
-            </a:r>
-          </a:p>
-          <a:p>
-            <a:pPr>
-              <a:spcAft>
-                <a:spcPts val="800"/>
-              </a:spcAft>
-            </a:pPr>
-            <a:r>
-              <a:rPr sz="1200" b="0">
-                <a:solidFill>
-                  <a:srgbClr val="1A1A1A"/>
-                </a:solidFill>
-              </a:rPr>
-              <a:t/>
-            </a:r>
-          </a:p>
-          <a:p>
-            <a:pPr>
-              <a:spcAft>
-                <a:spcPts val="800"/>
-              </a:spcAft>
-            </a:pPr>
-            <a:r>
-              <a:rPr sz="1200" b="0">
-                <a:solidFill>
-                  <a:srgbClr val="1A1A1A"/>
-                </a:solidFill>
-              </a:rPr>
-              <a:t>The detector is a single threshold. A real receiver discloses part of</a:t>
-            </a:r>
-          </a:p>
-          <a:p>
-            <a:pPr>
-              <a:spcAft>
-                <a:spcPts val="800"/>
-              </a:spcAft>
-            </a:pPr>
-            <a:r>
-              <a:rPr sz="1200" b="0">
-                <a:solidFill>
-                  <a:srgbClr val="1A1A1A"/>
-                </a:solidFill>
-              </a:rPr>
-              <a:t>the key, estimates QBER on that subset and adapts the threshold</a:t>
-            </a:r>
-          </a:p>
-          <a:p>
-            <a:pPr>
-              <a:spcAft>
-                <a:spcPts val="800"/>
-              </a:spcAft>
-            </a:pPr>
-            <a:r>
-              <a:rPr sz="1200" b="0">
-                <a:solidFill>
-                  <a:srgbClr val="1A1A1A"/>
-                </a:solidFill>
-              </a:rPr>
-              <a:t>against a measured baseline instead of a fixed number.</a:t>
-            </a:r>
-          </a:p>
-          <a:p>
-            <a:pPr>
-              <a:spcAft>
-                <a:spcPts val="800"/>
-              </a:spcAft>
-            </a:pPr>
-            <a:r>
-              <a:rPr sz="1200" b="0">
-                <a:solidFill>
-                  <a:srgbClr val="1A1A1A"/>
-                </a:solidFill>
-              </a:rPr>
-              <a:t/>
-            </a:r>
-          </a:p>
-          <a:p>
-            <a:pPr>
-              <a:spcAft>
-                <a:spcPts val="800"/>
-              </a:spcAft>
-            </a:pPr>
-            <a:r>
-              <a:rPr sz="1200" b="0">
-                <a:solidFill>
-                  <a:srgbClr val="1A1A1A"/>
-                </a:solidFill>
-              </a:rPr>
-              <a:t>The next version of this work would estimate the baseline online and</a:t>
-            </a:r>
-          </a:p>
-          <a:p>
-            <a:pPr>
-              <a:spcAft>
-                <a:spcPts val="800"/>
-              </a:spcAft>
-            </a:pPr>
-            <a:r>
-              <a:rPr sz="1200" b="0">
-                <a:solidFill>
-                  <a:srgbClr val="1A1A1A"/>
-                </a:solidFill>
-              </a:rPr>
-              <a:t>run the detection on the residual, which is the version that would</a:t>
-            </a:r>
-          </a:p>
-          <a:p>
-            <a:pPr>
-              <a:spcAft>
-                <a:spcPts val="800"/>
-              </a:spcAft>
-            </a:pPr>
-            <a:r>
-              <a:rPr sz="1200" b="0">
-                <a:solidFill>
-                  <a:srgbClr val="1A1A1A"/>
-                </a:solidFill>
-              </a:rPr>
-              <a:t>survive contact with a real link.</a:t>
+              <a:t>The next version of this work would estimate the baseline online and run the detection on the residual, which is the version that would survive contact with a real link.</a:t>
             </a:r>
           </a:p>
         </p:txBody>

</xml_diff>

<commit_message>
Restore line breaks in title slide and disclosure list
</commit_message>
<xml_diff>
--- a/report/evesense_deck.pptx
+++ b/report/evesense_deck.pptx
@@ -3206,7 +3206,37 @@
                   <a:srgbClr val="666666"/>
                 </a:solidFill>
               </a:rPr>
-              <a:t>Chiara De Venuto - team ChiaraDev Qiskit Fall Fest 2026 @ MPSTME, IBM Quantum Quantum Secure Communication track</a:t>
+              <a:t>Chiara De Venuto - team ChiaraDev</a:t>
+            </a:r>
+          </a:p>
+          <a:p>
+            <a:pPr>
+              <a:spcAft>
+                <a:spcPts val="1000"/>
+              </a:spcAft>
+            </a:pPr>
+            <a:r>
+              <a:rPr sz="1400" b="0">
+                <a:solidFill>
+                  <a:srgbClr val="666666"/>
+                </a:solidFill>
+              </a:rPr>
+              <a:t>Qiskit Fall Fest 2026 @ MPSTME, IBM Quantum</a:t>
+            </a:r>
+          </a:p>
+          <a:p>
+            <a:pPr>
+              <a:spcAft>
+                <a:spcPts val="1000"/>
+              </a:spcAft>
+            </a:pPr>
+            <a:r>
+              <a:rPr sz="1400" b="0">
+                <a:solidFill>
+                  <a:srgbClr val="666666"/>
+                </a:solidFill>
+              </a:rPr>
+              <a:t>Quantum Secure Communication track</a:t>
             </a:r>
           </a:p>
         </p:txBody>
@@ -3291,6 +3321,36 @@
           <a:p>
             <a:pPr>
               <a:spcAft>
+                <a:spcPts val="200"/>
+              </a:spcAft>
+            </a:pPr>
+            <a:r>
+              <a:rPr sz="1500" b="0">
+                <a:solidFill>
+                  <a:srgbClr val="666666"/>
+                </a:solidFill>
+              </a:rPr>
+              <a:t>This project was developed with the assistance of generative AI tools for research,</a:t>
+            </a:r>
+          </a:p>
+          <a:p>
+            <a:pPr>
+              <a:spcAft>
+                <a:spcPts val="200"/>
+              </a:spcAft>
+            </a:pPr>
+            <a:r>
+              <a:rPr sz="1500" b="0">
+                <a:solidFill>
+                  <a:srgbClr val="666666"/>
+                </a:solidFill>
+              </a:rPr>
+              <a:t>structuring and content generation. The final content has been reviewed and</a:t>
+            </a:r>
+          </a:p>
+          <a:p>
+            <a:pPr>
+              <a:spcAft>
                 <a:spcPts val="1000"/>
               </a:spcAft>
             </a:pPr>
@@ -3300,7 +3360,97 @@
                   <a:srgbClr val="666666"/>
                 </a:solidFill>
               </a:rPr>
-              <a:t>This project was developed with the assistance of generative AI tools for research, structuring and content generation. The final content has been reviewed and validated by the author.</a:t>
+              <a:t>validated by the author.</a:t>
+            </a:r>
+          </a:p>
+          <a:p>
+            <a:pPr>
+              <a:spcAft>
+                <a:spcPts val="200"/>
+              </a:spcAft>
+            </a:pPr>
+            <a:r>
+              <a:rPr sz="1500" b="0">
+                <a:solidFill>
+                  <a:srgbClr val="666666"/>
+                </a:solidFill>
+              </a:rPr>
+              <a:t>Full compliance with:</a:t>
+            </a:r>
+          </a:p>
+          <a:p>
+            <a:pPr>
+              <a:spcAft>
+                <a:spcPts val="200"/>
+              </a:spcAft>
+            </a:pPr>
+            <a:r>
+              <a:rPr sz="1500" b="0">
+                <a:solidFill>
+                  <a:srgbClr val="666666"/>
+                </a:solidFill>
+              </a:rPr>
+              <a:t>Reg. (EU) 2024/1689 (AI Act) Art. 50</a:t>
+            </a:r>
+          </a:p>
+          <a:p>
+            <a:pPr>
+              <a:spcAft>
+                <a:spcPts val="200"/>
+              </a:spcAft>
+            </a:pPr>
+            <a:r>
+              <a:rPr sz="1500" b="0">
+                <a:solidFill>
+                  <a:srgbClr val="666666"/>
+                </a:solidFill>
+              </a:rPr>
+              <a:t>Italian Law 132/2025 Art. 13</a:t>
+            </a:r>
+          </a:p>
+          <a:p>
+            <a:pPr>
+              <a:spcAft>
+                <a:spcPts val="200"/>
+              </a:spcAft>
+            </a:pPr>
+            <a:r>
+              <a:rPr sz="1500" b="0">
+                <a:solidFill>
+                  <a:srgbClr val="666666"/>
+                </a:solidFill>
+              </a:rPr>
+              <a:t>EU Code of Practice on AI Transparency (2026)</a:t>
+            </a:r>
+          </a:p>
+          <a:p>
+            <a:pPr>
+              <a:spcAft>
+                <a:spcPts val="200"/>
+              </a:spcAft>
+            </a:pPr>
+            <a:r>
+              <a:rPr sz="1500" b="0">
+                <a:solidFill>
+                  <a:srgbClr val="666666"/>
+                </a:solidFill>
+              </a:rPr>
+              <a:t>U.S. AI Labeling Act (S. 4915) - U.S. H.R.8479</a:t>
+            </a:r>
+          </a:p>
+          <a:p>
+            <a:pPr>
+              <a:spcAft>
+                <a:spcPts val="200"/>
+              </a:spcAft>
+            </a:pPr>
+            <a:r>
+              <a:rPr sz="1500" b="0">
+                <a:solidFill>
+                  <a:srgbClr val="666666"/>
+                </a:solidFill>
+              </a:rPr>
+              <a:t>U.S. Executive Order on AI (Dec 2025)</a:t>
             </a:r>
           </a:p>
           <a:p>
@@ -3315,7 +3465,7 @@
                   <a:srgbClr val="666666"/>
                 </a:solidFill>
               </a:rPr>
-              <a:t>Full compliance with: Reg. (EU) 2024/1689 (AI Act) Art. 50 Italian Law 132/2025 Art. 13 EU Code of Practice on AI Transparency (2026) U.S. AI Labeling Act (S. 4915) - U.S. H.R.8479 U.S. Executive Order on AI (Dec 2025) California TFAIA &amp; AB 2013 (eff. Jan 2026)</a:t>
+              <a:t>California TFAIA &amp; AB 2013 (eff. Jan 2026)</a:t>
             </a:r>
           </a:p>
         </p:txBody>
@@ -3400,6 +3550,51 @@
           <a:p>
             <a:pPr>
               <a:spcAft>
+                <a:spcPts val="200"/>
+              </a:spcAft>
+            </a:pPr>
+            <a:r>
+              <a:rPr sz="1600" b="0">
+                <a:solidFill>
+                  <a:srgbClr val="1A1A1A"/>
+                </a:solidFill>
+              </a:rPr>
+              <a:t>BB84 security rests on one fact: measuring a qubit in the wrong basis</a:t>
+            </a:r>
+          </a:p>
+          <a:p>
+            <a:pPr>
+              <a:spcAft>
+                <a:spcPts val="200"/>
+              </a:spcAft>
+            </a:pPr>
+            <a:r>
+              <a:rPr sz="1600" b="0">
+                <a:solidFill>
+                  <a:srgbClr val="1A1A1A"/>
+                </a:solidFill>
+              </a:rPr>
+              <a:t>disturbs it. An intercept-resend attacker inserts errors, the two ends</a:t>
+            </a:r>
+          </a:p>
+          <a:p>
+            <a:pPr>
+              <a:spcAft>
+                <a:spcPts val="200"/>
+              </a:spcAft>
+            </a:pPr>
+            <a:r>
+              <a:rPr sz="1600" b="0">
+                <a:solidFill>
+                  <a:srgbClr val="1A1A1A"/>
+                </a:solidFill>
+              </a:rPr>
+              <a:t>read those errors as QBER, and above roughly 11% QBER the link stops</a:t>
+            </a:r>
+          </a:p>
+          <a:p>
+            <a:pPr>
+              <a:spcAft>
                 <a:spcPts val="1000"/>
               </a:spcAft>
             </a:pPr>
@@ -3409,7 +3604,52 @@
                   <a:srgbClr val="1A1A1A"/>
                 </a:solidFill>
               </a:rPr>
-              <a:t>BB84 security rests on one fact: measuring a qubit in the wrong basis disturbs it. An intercept-resend attacker inserts errors, the two ends read those errors as QBER, and above roughly 11% QBER the link stops producing usable key.</a:t>
+              <a:t>producing usable key.</a:t>
+            </a:r>
+          </a:p>
+          <a:p>
+            <a:pPr>
+              <a:spcAft>
+                <a:spcPts val="200"/>
+              </a:spcAft>
+            </a:pPr>
+            <a:r>
+              <a:rPr sz="1600" b="0">
+                <a:solidFill>
+                  <a:srgbClr val="1A1A1A"/>
+                </a:solidFill>
+              </a:rPr>
+              <a:t>Deployed fiber is never clean. Raman scattering, dark counts and</a:t>
+            </a:r>
+          </a:p>
+          <a:p>
+            <a:pPr>
+              <a:spcAft>
+                <a:spcPts val="200"/>
+              </a:spcAft>
+            </a:pPr>
+            <a:r>
+              <a:rPr sz="1600" b="0">
+                <a:solidFill>
+                  <a:srgbClr val="1A1A1A"/>
+                </a:solidFill>
+              </a:rPr>
+              <a:t>polarization drift put real links at a few percent QBER with nobody</a:t>
+            </a:r>
+          </a:p>
+          <a:p>
+            <a:pPr>
+              <a:spcAft>
+                <a:spcPts val="200"/>
+              </a:spcAft>
+            </a:pPr>
+            <a:r>
+              <a:rPr sz="1600" b="0">
+                <a:solidFill>
+                  <a:srgbClr val="1A1A1A"/>
+                </a:solidFill>
+              </a:rPr>
+              <a:t>listening. So the receiver is not comparing a measurement against</a:t>
             </a:r>
           </a:p>
           <a:p>
@@ -3424,7 +3664,52 @@
                   <a:srgbClr val="1A1A1A"/>
                 </a:solidFill>
               </a:rPr>
-              <a:t>Deployed fiber is never clean. Raman scattering, dark counts and polarization drift put real links at a few percent QBER with nobody listening. So the receiver is not comparing a measurement against zero. It is comparing against a baseline that moves.</a:t>
+              <a:t>zero. It is comparing against a baseline that moves.</a:t>
+            </a:r>
+          </a:p>
+          <a:p>
+            <a:pPr>
+              <a:spcAft>
+                <a:spcPts val="200"/>
+              </a:spcAft>
+            </a:pPr>
+            <a:r>
+              <a:rPr sz="1600" b="0">
+                <a:solidFill>
+                  <a:srgbClr val="1A1A1A"/>
+                </a:solidFill>
+              </a:rPr>
+              <a:t>Eve knows the baseline. A patient attacker keeps her interception</a:t>
+            </a:r>
+          </a:p>
+          <a:p>
+            <a:pPr>
+              <a:spcAft>
+                <a:spcPts val="200"/>
+              </a:spcAft>
+            </a:pPr>
+            <a:r>
+              <a:rPr sz="1600" b="0">
+                <a:solidFill>
+                  <a:srgbClr val="1A1A1A"/>
+                </a:solidFill>
+              </a:rPr>
+              <a:t>rate under the noise floor. The receiver has one number and one</a:t>
+            </a:r>
+          </a:p>
+          <a:p>
+            <a:pPr>
+              <a:spcAft>
+                <a:spcPts val="200"/>
+              </a:spcAft>
+            </a:pPr>
+            <a:r>
+              <a:rPr sz="1600" b="0">
+                <a:solidFill>
+                  <a:srgbClr val="1A1A1A"/>
+                </a:solidFill>
+              </a:rPr>
+              <a:t>threshold, and has to decide whether a rise in QBER is Eve or the</a:t>
             </a:r>
           </a:p>
           <a:p>
@@ -3439,7 +3724,7 @@
                   <a:srgbClr val="1A1A1A"/>
                 </a:solidFill>
               </a:rPr>
-              <a:t>Eve knows the baseline. A patient attacker keeps her interception rate under the noise floor. The receiver has one number and one threshold, and has to decide whether a rise in QBER is Eve or the weather.</a:t>
+              <a:t>weather.</a:t>
             </a:r>
           </a:p>
         </p:txBody>
@@ -3524,6 +3809,21 @@
           <a:p>
             <a:pPr>
               <a:spcAft>
+                <a:spcPts val="200"/>
+              </a:spcAft>
+            </a:pPr>
+            <a:r>
+              <a:rPr sz="1600" b="0">
+                <a:solidFill>
+                  <a:srgbClr val="1A1A1A"/>
+                </a:solidFill>
+              </a:rPr>
+              <a:t>A BB84 link in Qiskit with a tunable attacker and a tunable channel,</a:t>
+            </a:r>
+          </a:p>
+          <a:p>
+            <a:pPr>
+              <a:spcAft>
                 <a:spcPts val="1000"/>
               </a:spcAft>
             </a:pPr>
@@ -3533,7 +3833,37 @@
                   <a:srgbClr val="1A1A1A"/>
                 </a:solidFill>
               </a:rPr>
-              <a:t>A BB84 link in Qiskit with a tunable attacker and a tunable channel, then a detection study across nine conditions.</a:t>
+              <a:t>then a detection study across nine conditions.</a:t>
+            </a:r>
+          </a:p>
+          <a:p>
+            <a:pPr>
+              <a:spcAft>
+                <a:spcPts val="200"/>
+              </a:spcAft>
+            </a:pPr>
+            <a:r>
+              <a:rPr sz="1600" b="0">
+                <a:solidFill>
+                  <a:srgbClr val="1A1A1A"/>
+                </a:solidFill>
+              </a:rPr>
+              <a:t>One round is one qubit: Alice prepares |0&gt;, |1&gt;, |+&gt; or |-&gt;, Eve</a:t>
+            </a:r>
+          </a:p>
+          <a:p>
+            <a:pPr>
+              <a:spcAft>
+                <a:spcPts val="200"/>
+              </a:spcAft>
+            </a:pPr>
+            <a:r>
+              <a:rPr sz="1600" b="0">
+                <a:solidFill>
+                  <a:srgbClr val="1A1A1A"/>
+                </a:solidFill>
+              </a:rPr>
+              <a:t>intercept-measures and resends when she is active, the channel adds</a:t>
             </a:r>
           </a:p>
           <a:p>
@@ -3548,7 +3878,52 @@
                   <a:srgbClr val="1A1A1A"/>
                 </a:solidFill>
               </a:rPr>
-              <a:t>One round is one qubit: Alice prepares |0&gt;, |1&gt;, |+&gt; or |-&gt;, Eve intercept-measures and resends when she is active, the channel adds depolarizing and readout noise, Bob measures in the basis he picked.</a:t>
+              <a:t>depolarizing and readout noise, Bob measures in the basis he picked.</a:t>
+            </a:r>
+          </a:p>
+          <a:p>
+            <a:pPr>
+              <a:spcAft>
+                <a:spcPts val="200"/>
+              </a:spcAft>
+            </a:pPr>
+            <a:r>
+              <a:rPr sz="1600" b="0">
+                <a:solidFill>
+                  <a:srgbClr val="1A1A1A"/>
+                </a:solidFill>
+              </a:rPr>
+              <a:t>Rounds are packed into batches of 64 qubits in a single stabilizer</a:t>
+            </a:r>
+          </a:p>
+          <a:p>
+            <a:pPr>
+              <a:spcAft>
+                <a:spcPts val="200"/>
+              </a:spcAft>
+            </a:pPr>
+            <a:r>
+              <a:rPr sz="1600" b="0">
+                <a:solidFill>
+                  <a:srgbClr val="1A1A1A"/>
+                </a:solidFill>
+              </a:rPr>
+              <a:t>circuit, so 30000 rounds cost milliseconds. Eve's outcome is drawn</a:t>
+            </a:r>
+          </a:p>
+          <a:p>
+            <a:pPr>
+              <a:spcAft>
+                <a:spcPts val="200"/>
+              </a:spcAft>
+            </a:pPr>
+            <a:r>
+              <a:rPr sz="1600" b="0">
+                <a:solidFill>
+                  <a:srgbClr val="1A1A1A"/>
+                </a:solidFill>
+              </a:rPr>
+              <a:t>from the Born rule, which is what a mid-circuit measure-and-resend</a:t>
             </a:r>
           </a:p>
           <a:p>
@@ -3563,7 +3938,22 @@
                   <a:srgbClr val="1A1A1A"/>
                 </a:solidFill>
               </a:rPr>
-              <a:t>Rounds are packed into batches of 64 qubits in a single stabilizer circuit, so 30000 rounds cost milliseconds. Eve's outcome is drawn from the Born rule, which is what a mid-circuit measure-and-resend gives.</a:t>
+              <a:t>gives.</a:t>
+            </a:r>
+          </a:p>
+          <a:p>
+            <a:pPr>
+              <a:spcAft>
+                <a:spcPts val="200"/>
+              </a:spcAft>
+            </a:pPr>
+            <a:r>
+              <a:rPr sz="1600" b="0">
+                <a:solidFill>
+                  <a:srgbClr val="1A1A1A"/>
+                </a:solidFill>
+              </a:rPr>
+              <a:t>Four experiments: interception sweep, channel noise sweep, detection</a:t>
             </a:r>
           </a:p>
           <a:p>
@@ -3578,7 +3968,7 @@
                   <a:srgbClr val="1A1A1A"/>
                 </a:solidFill>
               </a:rPr>
-              <a:t>Four experiments: interception sweep, channel noise sweep, detection study with 12 repeats per condition, and the secure key rate curve.</a:t>
+              <a:t>study with 12 repeats per condition, and the secure key rate curve.</a:t>
             </a:r>
           </a:p>
         </p:txBody>
@@ -4135,6 +4525,36 @@
           <a:p>
             <a:pPr>
               <a:spcAft>
+                <a:spcPts val="200"/>
+              </a:spcAft>
+            </a:pPr>
+            <a:r>
+              <a:rPr sz="1500" b="0">
+                <a:solidFill>
+                  <a:srgbClr val="1A1A1A"/>
+                </a:solidFill>
+              </a:rPr>
+              <a:t>On a clean link the protocol behaves exactly as theory predicts: QBER</a:t>
+            </a:r>
+          </a:p>
+          <a:p>
+            <a:pPr>
+              <a:spcAft>
+                <a:spcPts val="200"/>
+              </a:spcAft>
+            </a:pPr>
+            <a:r>
+              <a:rPr sz="1500" b="0">
+                <a:solidFill>
+                  <a:srgbClr val="1A1A1A"/>
+                </a:solidFill>
+              </a:rPr>
+              <a:t>tracks 25% of the interception probability, and the measured curve</a:t>
+            </a:r>
+          </a:p>
+          <a:p>
+            <a:pPr>
+              <a:spcAft>
                 <a:spcPts val="1000"/>
               </a:spcAft>
             </a:pPr>
@@ -4144,7 +4564,52 @@
                   <a:srgbClr val="1A1A1A"/>
                 </a:solidFill>
               </a:rPr>
-              <a:t>On a clean link the protocol behaves exactly as theory predicts: QBER tracks 25% of the interception probability, and the measured curve sits on the analytical one.</a:t>
+              <a:t>sits on the analytical one.</a:t>
+            </a:r>
+          </a:p>
+          <a:p>
+            <a:pPr>
+              <a:spcAft>
+                <a:spcPts val="200"/>
+              </a:spcAft>
+            </a:pPr>
+            <a:r>
+              <a:rPr sz="1500" b="0">
+                <a:solidFill>
+                  <a:srgbClr val="1A1A1A"/>
+                </a:solidFill>
+              </a:rPr>
+              <a:t>A 7% depolarizing channel on its own produces about 7% QBER. That</a:t>
+            </a:r>
+          </a:p>
+          <a:p>
+            <a:pPr>
+              <a:spcAft>
+                <a:spcPts val="200"/>
+              </a:spcAft>
+            </a:pPr>
+            <a:r>
+              <a:rPr sz="1500" b="0">
+                <a:solidFill>
+                  <a:srgbClr val="1A1A1A"/>
+                </a:solidFill>
+              </a:rPr>
+              <a:t>is the same order of magnitude as a 10% interception rate on clean</a:t>
+            </a:r>
+          </a:p>
+          <a:p>
+            <a:pPr>
+              <a:spcAft>
+                <a:spcPts val="200"/>
+              </a:spcAft>
+            </a:pPr>
+            <a:r>
+              <a:rPr sz="1500" b="0">
+                <a:solidFill>
+                  <a:srgbClr val="1A1A1A"/>
+                </a:solidFill>
+              </a:rPr>
+              <a:t>fiber. The receiver cannot tell those two apart from a single</a:t>
             </a:r>
           </a:p>
           <a:p>
@@ -4159,7 +4624,52 @@
                   <a:srgbClr val="1A1A1A"/>
                 </a:solidFill>
               </a:rPr>
-              <a:t>A 7% depolarizing channel on its own produces about 7% QBER. That is the same order of magnitude as a 10% interception rate on clean fiber. The receiver cannot tell those two apart from a single measurement.</a:t>
+              <a:t>measurement.</a:t>
+            </a:r>
+          </a:p>
+          <a:p>
+            <a:pPr>
+              <a:spcAft>
+                <a:spcPts val="200"/>
+              </a:spcAft>
+            </a:pPr>
+            <a:r>
+              <a:rPr sz="1500" b="0">
+                <a:solidFill>
+                  <a:srgbClr val="1A1A1A"/>
+                </a:solidFill>
+              </a:rPr>
+              <a:t>The ROC curves show the tradeoff. On clean fiber almost any</a:t>
+            </a:r>
+          </a:p>
+          <a:p>
+            <a:pPr>
+              <a:spcAft>
+                <a:spcPts val="200"/>
+              </a:spcAft>
+            </a:pPr>
+            <a:r>
+              <a:rPr sz="1500" b="0">
+                <a:solidFill>
+                  <a:srgbClr val="1A1A1A"/>
+                </a:solidFill>
+              </a:rPr>
+              <a:t>threshold separates tapped from untapped. On dirty fiber the curve</a:t>
+            </a:r>
+          </a:p>
+          <a:p>
+            <a:pPr>
+              <a:spcAft>
+                <a:spcPts val="200"/>
+              </a:spcAft>
+            </a:pPr>
+            <a:r>
+              <a:rPr sz="1500" b="0">
+                <a:solidFill>
+                  <a:srgbClr val="1A1A1A"/>
+                </a:solidFill>
+              </a:rPr>
+              <a:t>collapses toward the diagonal at low interception rates, which is</a:t>
             </a:r>
           </a:p>
           <a:p>
@@ -4174,7 +4684,22 @@
                   <a:srgbClr val="1A1A1A"/>
                 </a:solidFill>
               </a:rPr>
-              <a:t>The ROC curves show the tradeoff. On clean fiber almost any threshold separates tapped from untapped. On dirty fiber the curve collapses toward the diagonal at low interception rates, which is where a patient attacker works.</a:t>
+              <a:t>where a patient attacker works.</a:t>
+            </a:r>
+          </a:p>
+          <a:p>
+            <a:pPr>
+              <a:spcAft>
+                <a:spcPts val="200"/>
+              </a:spcAft>
+            </a:pPr>
+            <a:r>
+              <a:rPr sz="1500" b="0">
+                <a:solidFill>
+                  <a:srgbClr val="1A1A1A"/>
+                </a:solidFill>
+              </a:rPr>
+              <a:t>Past about 11% QBER error correction and privacy amplification take</a:t>
             </a:r>
           </a:p>
           <a:p>
@@ -4189,7 +4714,7 @@
                   <a:srgbClr val="1A1A1A"/>
                 </a:solidFill>
               </a:rPr>
-              <a:t>Past about 11% QBER error correction and privacy amplification take everything. The link stays up and stops being worth anything.</a:t>
+              <a:t>everything. The link stays up and stops being worth anything.</a:t>
             </a:r>
           </a:p>
         </p:txBody>
@@ -4274,6 +4799,36 @@
           <a:p>
             <a:pPr>
               <a:spcAft>
+                <a:spcPts val="200"/>
+              </a:spcAft>
+            </a:pPr>
+            <a:r>
+              <a:rPr sz="1500" b="0">
+                <a:solidFill>
+                  <a:srgbClr val="1A1A1A"/>
+                </a:solidFill>
+              </a:rPr>
+              <a:t>Eve here is a textbook intercept-resend attacker. Photon-number-</a:t>
+            </a:r>
+          </a:p>
+          <a:p>
+            <a:pPr>
+              <a:spcAft>
+                <a:spcPts val="200"/>
+              </a:spcAft>
+            </a:pPr>
+            <a:r>
+              <a:rPr sz="1500" b="0">
+                <a:solidFill>
+                  <a:srgbClr val="1A1A1A"/>
+                </a:solidFill>
+              </a:rPr>
+              <a:t>splitting and coherent attacks are not in the model, and nothing in</a:t>
+            </a:r>
+          </a:p>
+          <a:p>
+            <a:pPr>
+              <a:spcAft>
                 <a:spcPts val="1000"/>
               </a:spcAft>
             </a:pPr>
@@ -4283,7 +4838,22 @@
                   <a:srgbClr val="1A1A1A"/>
                 </a:solidFill>
               </a:rPr>
-              <a:t>Eve here is a textbook intercept-resend attacker. Photon-number- splitting and coherent attacks are not in the model, and nothing in this work is a security proof.</a:t>
+              <a:t>this work is a security proof.</a:t>
+            </a:r>
+          </a:p>
+          <a:p>
+            <a:pPr>
+              <a:spcAft>
+                <a:spcPts val="200"/>
+              </a:spcAft>
+            </a:pPr>
+            <a:r>
+              <a:rPr sz="1500" b="0">
+                <a:solidFill>
+                  <a:srgbClr val="1A1A1A"/>
+                </a:solidFill>
+              </a:rPr>
+              <a:t>The channel is depolarizing plus symmetric readout noise. Real fiber</a:t>
             </a:r>
           </a:p>
           <a:p>
@@ -4298,7 +4868,37 @@
                   <a:srgbClr val="1A1A1A"/>
                 </a:solidFill>
               </a:rPr>
-              <a:t>The channel is depolarizing plus symmetric readout noise. Real fiber drifts in polarization and loses differently per wavelength.</a:t>
+              <a:t>drifts in polarization and loses differently per wavelength.</a:t>
+            </a:r>
+          </a:p>
+          <a:p>
+            <a:pPr>
+              <a:spcAft>
+                <a:spcPts val="200"/>
+              </a:spcAft>
+            </a:pPr>
+            <a:r>
+              <a:rPr sz="1500" b="0">
+                <a:solidFill>
+                  <a:srgbClr val="1A1A1A"/>
+                </a:solidFill>
+              </a:rPr>
+              <a:t>The detector is a single threshold. A real receiver discloses part of</a:t>
+            </a:r>
+          </a:p>
+          <a:p>
+            <a:pPr>
+              <a:spcAft>
+                <a:spcPts val="200"/>
+              </a:spcAft>
+            </a:pPr>
+            <a:r>
+              <a:rPr sz="1500" b="0">
+                <a:solidFill>
+                  <a:srgbClr val="1A1A1A"/>
+                </a:solidFill>
+              </a:rPr>
+              <a:t>the key, estimates QBER on that subset and adapts the threshold</a:t>
             </a:r>
           </a:p>
           <a:p>
@@ -4313,7 +4913,37 @@
                   <a:srgbClr val="1A1A1A"/>
                 </a:solidFill>
               </a:rPr>
-              <a:t>The detector is a single threshold. A real receiver discloses part of the key, estimates QBER on that subset and adapts the threshold against a measured baseline instead of a fixed number.</a:t>
+              <a:t>against a measured baseline instead of a fixed number.</a:t>
+            </a:r>
+          </a:p>
+          <a:p>
+            <a:pPr>
+              <a:spcAft>
+                <a:spcPts val="200"/>
+              </a:spcAft>
+            </a:pPr>
+            <a:r>
+              <a:rPr sz="1500" b="0">
+                <a:solidFill>
+                  <a:srgbClr val="1A1A1A"/>
+                </a:solidFill>
+              </a:rPr>
+              <a:t>The next version of this work would estimate the baseline online and</a:t>
+            </a:r>
+          </a:p>
+          <a:p>
+            <a:pPr>
+              <a:spcAft>
+                <a:spcPts val="200"/>
+              </a:spcAft>
+            </a:pPr>
+            <a:r>
+              <a:rPr sz="1500" b="0">
+                <a:solidFill>
+                  <a:srgbClr val="1A1A1A"/>
+                </a:solidFill>
+              </a:rPr>
+              <a:t>run the detection on the residual, which is the version that would</a:t>
             </a:r>
           </a:p>
           <a:p>
@@ -4328,7 +4958,7 @@
                   <a:srgbClr val="1A1A1A"/>
                 </a:solidFill>
               </a:rPr>
-              <a:t>The next version of this work would estimate the baseline online and run the detection on the residual, which is the version that would survive contact with a real link.</a:t>
+              <a:t>survive contact with a real link.</a:t>
             </a:r>
           </a:p>
         </p:txBody>

</xml_diff>